<commit_message>
ring space version to test wether central fixation points matters
</commit_message>
<xml_diff>
--- a/Instructions.pptx
+++ b/Instructions.pptx
@@ -5,7 +5,7 @@
     <p:sldMasterId id="2147483648" r:id="rId1"/>
   </p:sldMasterIdLst>
   <p:notesMasterIdLst>
-    <p:notesMasterId r:id="rId17"/>
+    <p:notesMasterId r:id="rId18"/>
   </p:notesMasterIdLst>
   <p:sldIdLst>
     <p:sldId id="273" r:id="rId2"/>
@@ -20,9 +20,10 @@
     <p:sldId id="260" r:id="rId11"/>
     <p:sldId id="261" r:id="rId12"/>
     <p:sldId id="271" r:id="rId13"/>
-    <p:sldId id="279" r:id="rId14"/>
-    <p:sldId id="278" r:id="rId15"/>
-    <p:sldId id="277" r:id="rId16"/>
+    <p:sldId id="282" r:id="rId14"/>
+    <p:sldId id="279" r:id="rId15"/>
+    <p:sldId id="278" r:id="rId16"/>
+    <p:sldId id="277" r:id="rId17"/>
   </p:sldIdLst>
   <p:sldSz cx="12192000" cy="6858000"/>
   <p:notesSz cx="6858000" cy="9144000"/>
@@ -171,6 +172,7 @@
         </p14:section>
         <p14:section name="任务二 正式实验" id="{5E91EF60-2A33-4FB8-BE00-B2C3CA6CD8E4}">
           <p14:sldIdLst>
+            <p14:sldId id="282"/>
             <p14:sldId id="279"/>
           </p14:sldIdLst>
         </p14:section>
@@ -275,7 +277,7 @@
           <a:p>
             <a:fld id="{373AEA94-00EF-4DE4-8FA3-F9ECAA6DD2CF}" type="datetimeFigureOut">
               <a:rPr lang="zh-CN" altLang="en-US" smtClean="0"/>
-              <a:t>2026/1/20</a:t>
+              <a:t>2026/3/26</a:t>
             </a:fld>
             <a:endParaRPr lang="zh-CN" altLang="en-US"/>
           </a:p>
@@ -1445,7 +1447,7 @@
           <a:p>
             <a:fld id="{E45C1C0B-BEED-40A4-BB03-2B5E358FDD63}" type="datetimeFigureOut">
               <a:rPr lang="zh-CN" altLang="en-US" smtClean="0"/>
-              <a:t>2026/1/20</a:t>
+              <a:t>2026/3/26</a:t>
             </a:fld>
             <a:endParaRPr lang="zh-CN" altLang="en-US"/>
           </a:p>
@@ -1643,7 +1645,7 @@
           <a:p>
             <a:fld id="{E45C1C0B-BEED-40A4-BB03-2B5E358FDD63}" type="datetimeFigureOut">
               <a:rPr lang="zh-CN" altLang="en-US" smtClean="0"/>
-              <a:t>2026/1/20</a:t>
+              <a:t>2026/3/26</a:t>
             </a:fld>
             <a:endParaRPr lang="zh-CN" altLang="en-US"/>
           </a:p>
@@ -1851,7 +1853,7 @@
           <a:p>
             <a:fld id="{E45C1C0B-BEED-40A4-BB03-2B5E358FDD63}" type="datetimeFigureOut">
               <a:rPr lang="zh-CN" altLang="en-US" smtClean="0"/>
-              <a:t>2026/1/20</a:t>
+              <a:t>2026/3/26</a:t>
             </a:fld>
             <a:endParaRPr lang="zh-CN" altLang="en-US"/>
           </a:p>
@@ -2049,7 +2051,7 @@
           <a:p>
             <a:fld id="{E45C1C0B-BEED-40A4-BB03-2B5E358FDD63}" type="datetimeFigureOut">
               <a:rPr lang="zh-CN" altLang="en-US" smtClean="0"/>
-              <a:t>2026/1/20</a:t>
+              <a:t>2026/3/26</a:t>
             </a:fld>
             <a:endParaRPr lang="zh-CN" altLang="en-US"/>
           </a:p>
@@ -2324,7 +2326,7 @@
           <a:p>
             <a:fld id="{E45C1C0B-BEED-40A4-BB03-2B5E358FDD63}" type="datetimeFigureOut">
               <a:rPr lang="zh-CN" altLang="en-US" smtClean="0"/>
-              <a:t>2026/1/20</a:t>
+              <a:t>2026/3/26</a:t>
             </a:fld>
             <a:endParaRPr lang="zh-CN" altLang="en-US"/>
           </a:p>
@@ -2589,7 +2591,7 @@
           <a:p>
             <a:fld id="{E45C1C0B-BEED-40A4-BB03-2B5E358FDD63}" type="datetimeFigureOut">
               <a:rPr lang="zh-CN" altLang="en-US" smtClean="0"/>
-              <a:t>2026/1/20</a:t>
+              <a:t>2026/3/26</a:t>
             </a:fld>
             <a:endParaRPr lang="zh-CN" altLang="en-US"/>
           </a:p>
@@ -3001,7 +3003,7 @@
           <a:p>
             <a:fld id="{E45C1C0B-BEED-40A4-BB03-2B5E358FDD63}" type="datetimeFigureOut">
               <a:rPr lang="zh-CN" altLang="en-US" smtClean="0"/>
-              <a:t>2026/1/20</a:t>
+              <a:t>2026/3/26</a:t>
             </a:fld>
             <a:endParaRPr lang="zh-CN" altLang="en-US"/>
           </a:p>
@@ -3142,7 +3144,7 @@
           <a:p>
             <a:fld id="{E45C1C0B-BEED-40A4-BB03-2B5E358FDD63}" type="datetimeFigureOut">
               <a:rPr lang="zh-CN" altLang="en-US" smtClean="0"/>
-              <a:t>2026/1/20</a:t>
+              <a:t>2026/3/26</a:t>
             </a:fld>
             <a:endParaRPr lang="zh-CN" altLang="en-US"/>
           </a:p>
@@ -3255,7 +3257,7 @@
           <a:p>
             <a:fld id="{E45C1C0B-BEED-40A4-BB03-2B5E358FDD63}" type="datetimeFigureOut">
               <a:rPr lang="zh-CN" altLang="en-US" smtClean="0"/>
-              <a:t>2026/1/20</a:t>
+              <a:t>2026/3/26</a:t>
             </a:fld>
             <a:endParaRPr lang="zh-CN" altLang="en-US"/>
           </a:p>
@@ -3566,7 +3568,7 @@
           <a:p>
             <a:fld id="{E45C1C0B-BEED-40A4-BB03-2B5E358FDD63}" type="datetimeFigureOut">
               <a:rPr lang="zh-CN" altLang="en-US" smtClean="0"/>
-              <a:t>2026/1/20</a:t>
+              <a:t>2026/3/26</a:t>
             </a:fld>
             <a:endParaRPr lang="zh-CN" altLang="en-US"/>
           </a:p>
@@ -3854,7 +3856,7 @@
           <a:p>
             <a:fld id="{E45C1C0B-BEED-40A4-BB03-2B5E358FDD63}" type="datetimeFigureOut">
               <a:rPr lang="zh-CN" altLang="en-US" smtClean="0"/>
-              <a:t>2026/1/20</a:t>
+              <a:t>2026/3/26</a:t>
             </a:fld>
             <a:endParaRPr lang="zh-CN" altLang="en-US"/>
           </a:p>
@@ -4095,7 +4097,7 @@
           <a:p>
             <a:fld id="{E45C1C0B-BEED-40A4-BB03-2B5E358FDD63}" type="datetimeFigureOut">
               <a:rPr lang="zh-CN" altLang="en-US" smtClean="0"/>
-              <a:t>2026/1/20</a:t>
+              <a:t>2026/3/26</a:t>
             </a:fld>
             <a:endParaRPr lang="zh-CN" altLang="en-US"/>
           </a:p>
@@ -4654,7 +4656,7 @@
                 <a:ea typeface="楷体" panose="02010609060101010101" pitchFamily="49" charset="-122"/>
                 <a:cs typeface="+mn-cs"/>
               </a:rPr>
-              <a:t>实验共包含</a:t>
+              <a:t>实验预计</a:t>
             </a:r>
             <a:r>
               <a:rPr kumimoji="0" lang="zh-CN" altLang="en-US" sz="4000" b="1" i="0" u="sng" strike="noStrike" kern="1200" cap="none" spc="0" normalizeH="0" baseline="0" noProof="0" dirty="0">
@@ -4671,10 +4673,10 @@
                 <a:ea typeface="楷体" panose="02010609060101010101" pitchFamily="49" charset="-122"/>
                 <a:cs typeface="+mn-cs"/>
               </a:rPr>
-              <a:t>两个任务</a:t>
-            </a:r>
-            <a:r>
-              <a:rPr kumimoji="0" lang="zh-CN" altLang="en-US" sz="4000" b="0" i="0" u="none" strike="noStrike" kern="1200" cap="none" spc="0" normalizeH="0" baseline="0" noProof="0" dirty="0">
+              <a:t>用时</a:t>
+            </a:r>
+            <a:r>
+              <a:rPr kumimoji="0" lang="en-US" altLang="zh-CN" sz="4000" b="1" i="0" u="sng" strike="noStrike" kern="1200" cap="none" spc="0" normalizeH="0" baseline="0" noProof="0" dirty="0">
                 <a:ln>
                   <a:noFill/>
                 </a:ln>
@@ -4688,7 +4690,17 @@
                 <a:ea typeface="楷体" panose="02010609060101010101" pitchFamily="49" charset="-122"/>
                 <a:cs typeface="+mn-cs"/>
               </a:rPr>
-              <a:t>，预计</a:t>
+              <a:t>1</a:t>
+            </a:r>
+            <a:r>
+              <a:rPr lang="en-US" altLang="zh-CN" sz="4000" b="1" u="sng" dirty="0">
+                <a:solidFill>
+                  <a:prstClr val="black"/>
+                </a:solidFill>
+                <a:latin typeface="楷体" panose="02010609060101010101" pitchFamily="49" charset="-122"/>
+                <a:ea typeface="楷体" panose="02010609060101010101" pitchFamily="49" charset="-122"/>
+              </a:rPr>
+              <a:t>.5</a:t>
             </a:r>
             <a:r>
               <a:rPr kumimoji="0" lang="zh-CN" altLang="en-US" sz="4000" b="1" i="0" u="sng" strike="noStrike" kern="1200" cap="none" spc="0" normalizeH="0" baseline="0" noProof="0" dirty="0">
@@ -4705,10 +4717,10 @@
                 <a:ea typeface="楷体" panose="02010609060101010101" pitchFamily="49" charset="-122"/>
                 <a:cs typeface="+mn-cs"/>
               </a:rPr>
-              <a:t>用时</a:t>
-            </a:r>
-            <a:r>
-              <a:rPr kumimoji="0" lang="en-US" altLang="zh-CN" sz="4000" b="1" i="0" u="sng" strike="noStrike" kern="1200" cap="none" spc="0" normalizeH="0" baseline="0" noProof="0" dirty="0">
+              <a:t>小时</a:t>
+            </a:r>
+            <a:r>
+              <a:rPr kumimoji="0" lang="zh-CN" altLang="en-US" sz="4000" b="1" i="0" strike="noStrike" kern="1200" cap="none" spc="0" normalizeH="0" baseline="0" noProof="0" dirty="0">
                 <a:ln>
                   <a:noFill/>
                 </a:ln>
@@ -4722,10 +4734,10 @@
                 <a:ea typeface="楷体" panose="02010609060101010101" pitchFamily="49" charset="-122"/>
                 <a:cs typeface="+mn-cs"/>
               </a:rPr>
-              <a:t>1</a:t>
-            </a:r>
-            <a:r>
-              <a:rPr kumimoji="0" lang="zh-CN" altLang="en-US" sz="4000" b="1" i="0" u="sng" strike="noStrike" kern="1200" cap="none" spc="0" normalizeH="0" baseline="0" noProof="0" dirty="0">
+              <a:t>，</a:t>
+            </a:r>
+            <a:r>
+              <a:rPr kumimoji="0" lang="zh-CN" altLang="en-US" sz="4000" i="0" strike="noStrike" kern="1200" cap="none" spc="0" normalizeH="0" baseline="0" noProof="0" dirty="0">
                 <a:ln>
                   <a:noFill/>
                 </a:ln>
@@ -4739,9 +4751,9 @@
                 <a:ea typeface="楷体" panose="02010609060101010101" pitchFamily="49" charset="-122"/>
                 <a:cs typeface="+mn-cs"/>
               </a:rPr>
-              <a:t>小时</a:t>
-            </a:r>
-            <a:endParaRPr kumimoji="0" lang="en-US" altLang="zh-CN" sz="4000" b="1" i="0" u="sng" strike="noStrike" kern="1200" cap="none" spc="0" normalizeH="0" baseline="0" noProof="0" dirty="0">
+              <a:t>期间可以休息</a:t>
+            </a:r>
+            <a:endParaRPr kumimoji="0" lang="en-US" altLang="zh-CN" sz="4000" i="0" strike="noStrike" kern="1200" cap="none" spc="0" normalizeH="0" baseline="0" noProof="0" dirty="0">
               <a:ln>
                 <a:noFill/>
               </a:ln>
@@ -4775,6 +4787,16 @@
               <a:defRPr/>
             </a:pPr>
             <a:r>
+              <a:rPr lang="zh-CN" altLang="en-US" sz="4000" dirty="0">
+                <a:solidFill>
+                  <a:prstClr val="black"/>
+                </a:solidFill>
+                <a:latin typeface="楷体" panose="02010609060101010101" pitchFamily="49" charset="-122"/>
+                <a:ea typeface="楷体" panose="02010609060101010101" pitchFamily="49" charset="-122"/>
+              </a:rPr>
+              <a:t>认真完成实验，</a:t>
+            </a:r>
+            <a:r>
               <a:rPr kumimoji="0" lang="zh-CN" altLang="en-US" sz="4000" b="0" i="0" u="none" strike="noStrike" kern="1200" cap="none" spc="0" normalizeH="0" baseline="0" noProof="0" dirty="0">
                 <a:ln>
                   <a:noFill/>
@@ -4789,61 +4811,20 @@
                 <a:ea typeface="楷体" panose="02010609060101010101" pitchFamily="49" charset="-122"/>
                 <a:cs typeface="+mn-cs"/>
               </a:rPr>
-              <a:t>正式实验约</a:t>
-            </a:r>
-            <a:r>
-              <a:rPr kumimoji="0" lang="en-US" altLang="zh-CN" sz="4000" b="0" i="0" u="none" strike="noStrike" kern="1200" cap="none" spc="0" normalizeH="0" baseline="0" noProof="0" dirty="0">
-                <a:ln>
-                  <a:noFill/>
-                </a:ln>
-                <a:solidFill>
-                  <a:prstClr val="black"/>
-                </a:solidFill>
-                <a:effectLst/>
-                <a:uLnTx/>
-                <a:uFillTx/>
-                <a:latin typeface="楷体" panose="02010609060101010101" pitchFamily="49" charset="-122"/>
-                <a:ea typeface="楷体" panose="02010609060101010101" pitchFamily="49" charset="-122"/>
-                <a:cs typeface="+mn-cs"/>
-              </a:rPr>
-              <a:t>1</a:t>
-            </a:r>
-            <a:r>
-              <a:rPr kumimoji="0" lang="zh-CN" altLang="en-US" sz="4000" b="0" i="0" u="none" strike="noStrike" kern="1200" cap="none" spc="0" normalizeH="0" baseline="0" noProof="0" dirty="0">
-                <a:ln>
-                  <a:noFill/>
-                </a:ln>
-                <a:solidFill>
-                  <a:prstClr val="black"/>
-                </a:solidFill>
-                <a:effectLst/>
-                <a:uLnTx/>
-                <a:uFillTx/>
-                <a:latin typeface="楷体" panose="02010609060101010101" pitchFamily="49" charset="-122"/>
-                <a:ea typeface="楷体" panose="02010609060101010101" pitchFamily="49" charset="-122"/>
-                <a:cs typeface="+mn-cs"/>
-              </a:rPr>
-              <a:t>个小时，平均可获</a:t>
-            </a:r>
-            <a:r>
-              <a:rPr kumimoji="0" lang="en-US" altLang="zh-CN" sz="4000" b="0" i="0" u="none" strike="noStrike" kern="1200" cap="none" spc="0" normalizeH="0" baseline="0" noProof="0" dirty="0">
-                <a:ln>
-                  <a:noFill/>
-                </a:ln>
-                <a:solidFill>
-                  <a:prstClr val="black"/>
-                </a:solidFill>
-                <a:effectLst/>
-                <a:uLnTx/>
-                <a:uFillTx/>
-                <a:latin typeface="楷体" panose="02010609060101010101" pitchFamily="49" charset="-122"/>
-                <a:ea typeface="楷体" panose="02010609060101010101" pitchFamily="49" charset="-122"/>
-                <a:cs typeface="+mn-cs"/>
-              </a:rPr>
-              <a:t>50</a:t>
-            </a:r>
-            <a:r>
-              <a:rPr kumimoji="0" lang="zh-CN" altLang="en-US" sz="4000" b="0" i="0" u="none" strike="noStrike" kern="1200" cap="none" spc="0" normalizeH="0" baseline="0" noProof="0" dirty="0">
+              <a:t>平均可获</a:t>
+            </a:r>
+            <a:r>
+              <a:rPr lang="en-US" altLang="zh-CN" sz="4000" dirty="0">
+                <a:solidFill>
+                  <a:prstClr val="black"/>
+                </a:solidFill>
+                <a:latin typeface="楷体" panose="02010609060101010101" pitchFamily="49" charset="-122"/>
+                <a:ea typeface="楷体" panose="02010609060101010101" pitchFamily="49" charset="-122"/>
+              </a:rPr>
+              <a:t>75</a:t>
+            </a:r>
+            <a:r>
+              <a:rPr kumimoji="0" lang="zh-CN" altLang="en-US" sz="4000" b="0" i="0" u="none" strike="noStrike" kern="1200" cap="none" spc="0" normalizeH="0" baseline="0" noProof="0">
                 <a:ln>
                   <a:noFill/>
                 </a:ln>
@@ -8527,35 +8508,27 @@
               <a:t>”</a:t>
             </a:r>
             <a:r>
-              <a:rPr kumimoji="0" lang="zh-CN" altLang="en-US" sz="2800" b="1" i="0" u="none" strike="noStrike" kern="1200" cap="none" spc="0" normalizeH="0" baseline="0" noProof="0" dirty="0">
-                <a:ln>
-                  <a:noFill/>
-                </a:ln>
-                <a:solidFill>
-                  <a:srgbClr val="FF0000"/>
-                </a:solidFill>
-                <a:effectLst/>
-                <a:uLnTx/>
-                <a:uFillTx/>
-                <a:latin typeface="黑体" panose="02010609060101010101" pitchFamily="49" charset="-122"/>
-                <a:ea typeface="黑体" panose="02010609060101010101" pitchFamily="49" charset="-122"/>
-                <a:cs typeface="+mn-cs"/>
-              </a:rPr>
-              <a:t>开始</a:t>
-            </a:r>
-            <a:endParaRPr kumimoji="0" lang="zh-CN" altLang="en-US" sz="1200" b="1" i="0" u="none" strike="noStrike" kern="1200" cap="none" spc="0" normalizeH="0" baseline="0" noProof="0" dirty="0">
+              <a:rPr kumimoji="0" lang="zh-CN" altLang="en-US" sz="2800" i="0" u="none" strike="noStrike" kern="1200" cap="none" spc="0" normalizeH="0" baseline="0" noProof="0" dirty="0">
+                <a:ln>
+                  <a:noFill/>
+                </a:ln>
+                <a:effectLst/>
+                <a:uLnTx/>
+                <a:uFillTx/>
+                <a:latin typeface="楷体" panose="02010609060101010101" pitchFamily="49" charset="-122"/>
+                <a:ea typeface="楷体" panose="02010609060101010101" pitchFamily="49" charset="-122"/>
+              </a:rPr>
+              <a:t>继续</a:t>
+            </a:r>
+            <a:endParaRPr kumimoji="0" lang="zh-CN" altLang="en-US" sz="1200" i="0" u="none" strike="noStrike" kern="1200" cap="none" spc="0" normalizeH="0" baseline="0" noProof="0" dirty="0">
               <a:ln>
                 <a:noFill/>
               </a:ln>
-              <a:solidFill>
-                <a:srgbClr val="FF0000"/>
-              </a:solidFill>
               <a:effectLst/>
               <a:uLnTx/>
               <a:uFillTx/>
-              <a:latin typeface="黑体" panose="02010609060101010101" pitchFamily="49" charset="-122"/>
-              <a:ea typeface="黑体" panose="02010609060101010101" pitchFamily="49" charset="-122"/>
-              <a:cs typeface="+mn-cs"/>
+              <a:latin typeface="楷体" panose="02010609060101010101" pitchFamily="49" charset="-122"/>
+              <a:ea typeface="楷体" panose="02010609060101010101" pitchFamily="49" charset="-122"/>
             </a:endParaRPr>
           </a:p>
         </p:txBody>
@@ -8598,6 +8571,778 @@
     </p:spTree>
     <p:extLst>
       <p:ext uri="{BB962C8B-B14F-4D97-AF65-F5344CB8AC3E}">
+        <p14:creationId xmlns:p14="http://schemas.microsoft.com/office/powerpoint/2010/main" val="1658203442"/>
+      </p:ext>
+    </p:extLst>
+  </p:cSld>
+  <p:clrMapOvr>
+    <a:masterClrMapping/>
+  </p:clrMapOvr>
+</p:sld>
+</file>
+
+<file path=ppt/slides/slide14.xml><?xml version="1.0" encoding="utf-8"?>
+<p:sld xmlns:a="http://schemas.openxmlformats.org/drawingml/2006/main" xmlns:r="http://schemas.openxmlformats.org/officeDocument/2006/relationships" xmlns:p="http://schemas.openxmlformats.org/presentationml/2006/main">
+  <p:cSld>
+    <p:bg>
+      <p:bgPr>
+        <a:solidFill>
+          <a:schemeClr val="tx1">
+            <a:lumMod val="50000"/>
+            <a:lumOff val="50000"/>
+          </a:schemeClr>
+        </a:solidFill>
+        <a:effectLst/>
+      </p:bgPr>
+    </p:bg>
+    <p:spTree>
+      <p:nvGrpSpPr>
+        <p:cNvPr id="1" name="">
+          <a:extLst>
+            <a:ext uri="{FF2B5EF4-FFF2-40B4-BE49-F238E27FC236}">
+              <a16:creationId xmlns:a16="http://schemas.microsoft.com/office/drawing/2014/main" id="{88D91545-4F1F-9411-2960-5739C3EFA610}"/>
+            </a:ext>
+          </a:extLst>
+        </p:cNvPr>
+        <p:cNvGrpSpPr/>
+        <p:nvPr/>
+      </p:nvGrpSpPr>
+      <p:grpSpPr>
+        <a:xfrm>
+          <a:off x="0" y="0"/>
+          <a:ext cx="0" cy="0"/>
+          <a:chOff x="0" y="0"/>
+          <a:chExt cx="0" cy="0"/>
+        </a:xfrm>
+      </p:grpSpPr>
+      <p:sp>
+        <p:nvSpPr>
+          <p:cNvPr id="4" name="文本框 3">
+            <a:extLst>
+              <a:ext uri="{FF2B5EF4-FFF2-40B4-BE49-F238E27FC236}">
+                <a16:creationId xmlns:a16="http://schemas.microsoft.com/office/drawing/2014/main" id="{4C19970D-795F-8CA4-674B-CE3516C7E879}"/>
+              </a:ext>
+            </a:extLst>
+          </p:cNvPr>
+          <p:cNvSpPr txBox="1"/>
+          <p:nvPr/>
+        </p:nvSpPr>
+        <p:spPr>
+          <a:xfrm>
+            <a:off x="2729049" y="515981"/>
+            <a:ext cx="6733902" cy="923330"/>
+          </a:xfrm>
+          <a:prstGeom prst="rect">
+            <a:avLst/>
+          </a:prstGeom>
+          <a:noFill/>
+        </p:spPr>
+        <p:txBody>
+          <a:bodyPr wrap="square" rtlCol="0">
+            <a:spAutoFit/>
+          </a:bodyPr>
+          <a:lstStyle/>
+          <a:p>
+            <a:pPr marL="0" marR="0" lvl="0" indent="0" algn="ctr" defTabSz="914400" rtl="0" eaLnBrk="1" fontAlgn="auto" latinLnBrk="0" hangingPunct="1">
+              <a:lnSpc>
+                <a:spcPct val="100000"/>
+              </a:lnSpc>
+              <a:spcBef>
+                <a:spcPts val="0"/>
+              </a:spcBef>
+              <a:spcAft>
+                <a:spcPts val="0"/>
+              </a:spcAft>
+              <a:buClrTx/>
+              <a:buSzTx/>
+              <a:buFontTx/>
+              <a:buNone/>
+              <a:tabLst/>
+              <a:defRPr/>
+            </a:pPr>
+            <a:r>
+              <a:rPr kumimoji="0" lang="zh-CN" altLang="en-US" sz="5400" b="0" i="0" u="none" strike="noStrike" kern="1200" cap="none" spc="0" normalizeH="0" baseline="0" noProof="0" dirty="0">
+                <a:ln>
+                  <a:noFill/>
+                </a:ln>
+                <a:solidFill>
+                  <a:prstClr val="black"/>
+                </a:solidFill>
+                <a:effectLst/>
+                <a:uLnTx/>
+                <a:uFillTx/>
+                <a:latin typeface="楷体" panose="02010609060101010101" pitchFamily="49" charset="-122"/>
+                <a:ea typeface="楷体" panose="02010609060101010101" pitchFamily="49" charset="-122"/>
+                <a:cs typeface="+mn-cs"/>
+              </a:rPr>
+              <a:t>正式实验</a:t>
+            </a:r>
+          </a:p>
+        </p:txBody>
+      </p:sp>
+      <p:sp>
+        <p:nvSpPr>
+          <p:cNvPr id="6" name="文本框 5">
+            <a:extLst>
+              <a:ext uri="{FF2B5EF4-FFF2-40B4-BE49-F238E27FC236}">
+                <a16:creationId xmlns:a16="http://schemas.microsoft.com/office/drawing/2014/main" id="{BCBF8823-E7CD-5669-CB54-04211FDD59C1}"/>
+              </a:ext>
+            </a:extLst>
+          </p:cNvPr>
+          <p:cNvSpPr txBox="1"/>
+          <p:nvPr/>
+        </p:nvSpPr>
+        <p:spPr>
+          <a:xfrm>
+            <a:off x="1037571" y="1612442"/>
+            <a:ext cx="10504571" cy="4152099"/>
+          </a:xfrm>
+          <a:prstGeom prst="rect">
+            <a:avLst/>
+          </a:prstGeom>
+          <a:noFill/>
+        </p:spPr>
+        <p:txBody>
+          <a:bodyPr wrap="square" rtlCol="0">
+            <a:spAutoFit/>
+          </a:bodyPr>
+          <a:lstStyle/>
+          <a:p>
+            <a:pPr marL="685800" lvl="0" indent="-685800">
+              <a:lnSpc>
+                <a:spcPct val="125000"/>
+              </a:lnSpc>
+              <a:buFont typeface="Wingdings" panose="05000000000000000000" pitchFamily="2" charset="2"/>
+              <a:buChar char="p"/>
+              <a:defRPr/>
+            </a:pPr>
+            <a:r>
+              <a:rPr kumimoji="0" lang="zh-CN" altLang="en-US" sz="3600" b="0" i="0" u="none" strike="noStrike" kern="1200" cap="none" spc="0" normalizeH="0" baseline="0" noProof="0" dirty="0">
+                <a:ln>
+                  <a:noFill/>
+                </a:ln>
+                <a:solidFill>
+                  <a:prstClr val="black"/>
+                </a:solidFill>
+                <a:effectLst/>
+                <a:uLnTx/>
+                <a:uFillTx/>
+                <a:latin typeface="楷体" panose="02010609060101010101" pitchFamily="49" charset="-122"/>
+                <a:ea typeface="楷体" panose="02010609060101010101" pitchFamily="49" charset="-122"/>
+                <a:cs typeface="+mn-cs"/>
+              </a:rPr>
+              <a:t>小光斑颜色会</a:t>
+            </a:r>
+            <a:r>
+              <a:rPr kumimoji="0" lang="zh-CN" altLang="en-US" sz="3600" b="1" i="0" u="none" strike="noStrike" kern="1200" cap="none" spc="0" normalizeH="0" baseline="0" noProof="0" dirty="0">
+                <a:ln>
+                  <a:noFill/>
+                </a:ln>
+                <a:solidFill>
+                  <a:prstClr val="black"/>
+                </a:solidFill>
+                <a:effectLst/>
+                <a:uLnTx/>
+                <a:uFillTx/>
+                <a:latin typeface="楷体" panose="02010609060101010101" pitchFamily="49" charset="-122"/>
+                <a:ea typeface="楷体" panose="02010609060101010101" pitchFamily="49" charset="-122"/>
+                <a:cs typeface="+mn-cs"/>
+              </a:rPr>
+              <a:t>变淡</a:t>
+            </a:r>
+            <a:r>
+              <a:rPr kumimoji="0" lang="zh-CN" altLang="en-US" sz="3600" b="0" i="0" u="none" strike="noStrike" kern="1200" cap="none" spc="0" normalizeH="0" baseline="0" noProof="0" dirty="0">
+                <a:ln>
+                  <a:noFill/>
+                </a:ln>
+                <a:solidFill>
+                  <a:prstClr val="black"/>
+                </a:solidFill>
+                <a:effectLst/>
+                <a:uLnTx/>
+                <a:uFillTx/>
+                <a:latin typeface="楷体" panose="02010609060101010101" pitchFamily="49" charset="-122"/>
+                <a:ea typeface="楷体" panose="02010609060101010101" pitchFamily="49" charset="-122"/>
+                <a:cs typeface="+mn-cs"/>
+              </a:rPr>
+              <a:t>从而提高难度，但是</a:t>
+            </a:r>
+            <a:r>
+              <a:rPr kumimoji="0" lang="zh-CN" altLang="en-US" sz="3600" b="1" i="0" u="none" strike="noStrike" kern="1200" cap="none" spc="0" normalizeH="0" baseline="0" noProof="0" dirty="0">
+                <a:ln>
+                  <a:noFill/>
+                </a:ln>
+                <a:solidFill>
+                  <a:prstClr val="black"/>
+                </a:solidFill>
+                <a:effectLst/>
+                <a:uLnTx/>
+                <a:uFillTx/>
+                <a:latin typeface="楷体" panose="02010609060101010101" pitchFamily="49" charset="-122"/>
+                <a:ea typeface="楷体" panose="02010609060101010101" pitchFamily="49" charset="-122"/>
+                <a:cs typeface="+mn-cs"/>
+              </a:rPr>
+              <a:t>形状、大小、纹理</a:t>
+            </a:r>
+            <a:r>
+              <a:rPr kumimoji="0" lang="zh-CN" altLang="en-US" sz="3600" b="0" i="0" u="none" strike="noStrike" kern="1200" cap="none" spc="0" normalizeH="0" baseline="0" noProof="0" dirty="0">
+                <a:ln>
+                  <a:noFill/>
+                </a:ln>
+                <a:solidFill>
+                  <a:prstClr val="black"/>
+                </a:solidFill>
+                <a:effectLst/>
+                <a:uLnTx/>
+                <a:uFillTx/>
+                <a:latin typeface="楷体" panose="02010609060101010101" pitchFamily="49" charset="-122"/>
+                <a:ea typeface="楷体" panose="02010609060101010101" pitchFamily="49" charset="-122"/>
+                <a:cs typeface="+mn-cs"/>
+              </a:rPr>
+              <a:t>都不会变，请确认找到再按键。</a:t>
+            </a:r>
+            <a:endParaRPr lang="en-US" altLang="zh-CN" sz="3600" dirty="0">
+              <a:solidFill>
+                <a:prstClr val="black"/>
+              </a:solidFill>
+              <a:latin typeface="楷体" panose="02010609060101010101" pitchFamily="49" charset="-122"/>
+              <a:ea typeface="楷体" panose="02010609060101010101" pitchFamily="49" charset="-122"/>
+            </a:endParaRPr>
+          </a:p>
+          <a:p>
+            <a:pPr marL="685800" lvl="0" indent="-685800">
+              <a:lnSpc>
+                <a:spcPct val="125000"/>
+              </a:lnSpc>
+              <a:buFont typeface="Wingdings" panose="05000000000000000000" pitchFamily="2" charset="2"/>
+              <a:buChar char="p"/>
+              <a:defRPr/>
+            </a:pPr>
+            <a:r>
+              <a:rPr lang="zh-CN" altLang="en-US" sz="3600" dirty="0">
+                <a:solidFill>
+                  <a:prstClr val="black"/>
+                </a:solidFill>
+                <a:latin typeface="楷体" panose="02010609060101010101" pitchFamily="49" charset="-122"/>
+                <a:ea typeface="楷体" panose="02010609060101010101" pitchFamily="49" charset="-122"/>
+              </a:rPr>
+              <a:t>因难度提高，可能只能找到一半，</a:t>
+            </a:r>
+            <a:r>
+              <a:rPr lang="zh-CN" altLang="en-US" sz="3600" b="1" dirty="0">
+                <a:solidFill>
+                  <a:prstClr val="black"/>
+                </a:solidFill>
+                <a:latin typeface="楷体" panose="02010609060101010101" pitchFamily="49" charset="-122"/>
+                <a:ea typeface="楷体" panose="02010609060101010101" pitchFamily="49" charset="-122"/>
+              </a:rPr>
+              <a:t>这是正常的</a:t>
+            </a:r>
+            <a:r>
+              <a:rPr lang="zh-CN" altLang="en-US" sz="3600" dirty="0">
+                <a:solidFill>
+                  <a:prstClr val="black"/>
+                </a:solidFill>
+                <a:latin typeface="楷体" panose="02010609060101010101" pitchFamily="49" charset="-122"/>
+                <a:ea typeface="楷体" panose="02010609060101010101" pitchFamily="49" charset="-122"/>
+              </a:rPr>
+              <a:t>。</a:t>
+            </a:r>
+          </a:p>
+          <a:p>
+            <a:pPr marL="685800" lvl="0" indent="-685800">
+              <a:lnSpc>
+                <a:spcPct val="125000"/>
+              </a:lnSpc>
+              <a:buFont typeface="Wingdings" panose="05000000000000000000" pitchFamily="2" charset="2"/>
+              <a:buChar char="p"/>
+              <a:defRPr/>
+            </a:pPr>
+            <a:r>
+              <a:rPr lang="en-US" altLang="zh-CN" sz="3600" dirty="0">
+                <a:solidFill>
+                  <a:prstClr val="black"/>
+                </a:solidFill>
+                <a:latin typeface="楷体" panose="02010609060101010101" pitchFamily="49" charset="-122"/>
+                <a:ea typeface="楷体" panose="02010609060101010101" pitchFamily="49" charset="-122"/>
+              </a:rPr>
+              <a:t>5</a:t>
+            </a:r>
+            <a:r>
+              <a:rPr lang="zh-CN" altLang="en-US" sz="3600" dirty="0">
+                <a:solidFill>
+                  <a:prstClr val="black"/>
+                </a:solidFill>
+                <a:latin typeface="楷体" panose="02010609060101010101" pitchFamily="49" charset="-122"/>
+                <a:ea typeface="楷体" panose="02010609060101010101" pitchFamily="49" charset="-122"/>
+              </a:rPr>
+              <a:t>秒计时结束后，程序会自动帮你按下两个按键，并出现一个标记你最后注视位置的蓝点或者黄点，注意这</a:t>
+            </a:r>
+            <a:r>
+              <a:rPr lang="zh-CN" altLang="en-US" sz="3600" b="1" dirty="0">
+                <a:solidFill>
+                  <a:prstClr val="black"/>
+                </a:solidFill>
+                <a:latin typeface="楷体" panose="02010609060101010101" pitchFamily="49" charset="-122"/>
+                <a:ea typeface="楷体" panose="02010609060101010101" pitchFamily="49" charset="-122"/>
+              </a:rPr>
+              <a:t>不是答案</a:t>
+            </a:r>
+            <a:r>
+              <a:rPr lang="zh-CN" altLang="en-US" sz="3600" dirty="0">
+                <a:solidFill>
+                  <a:prstClr val="black"/>
+                </a:solidFill>
+                <a:latin typeface="楷体" panose="02010609060101010101" pitchFamily="49" charset="-122"/>
+                <a:ea typeface="楷体" panose="02010609060101010101" pitchFamily="49" charset="-122"/>
+              </a:rPr>
+              <a:t>位置。</a:t>
+            </a:r>
+            <a:endParaRPr lang="en-US" altLang="zh-CN" sz="3600" dirty="0">
+              <a:solidFill>
+                <a:prstClr val="black"/>
+              </a:solidFill>
+              <a:latin typeface="楷体" panose="02010609060101010101" pitchFamily="49" charset="-122"/>
+              <a:ea typeface="楷体" panose="02010609060101010101" pitchFamily="49" charset="-122"/>
+            </a:endParaRPr>
+          </a:p>
+        </p:txBody>
+      </p:sp>
+      <p:sp>
+        <p:nvSpPr>
+          <p:cNvPr id="7" name="椭圆 6">
+            <a:extLst>
+              <a:ext uri="{FF2B5EF4-FFF2-40B4-BE49-F238E27FC236}">
+                <a16:creationId xmlns:a16="http://schemas.microsoft.com/office/drawing/2014/main" id="{0C58A188-F879-48FC-4777-4ABD0F9204F7}"/>
+              </a:ext>
+            </a:extLst>
+          </p:cNvPr>
+          <p:cNvSpPr/>
+          <p:nvPr/>
+        </p:nvSpPr>
+        <p:spPr>
+          <a:xfrm>
+            <a:off x="8948060" y="5051714"/>
+            <a:ext cx="306977" cy="306977"/>
+          </a:xfrm>
+          <a:prstGeom prst="ellipse">
+            <a:avLst/>
+          </a:prstGeom>
+          <a:solidFill>
+            <a:srgbClr val="0070C0"/>
+          </a:solidFill>
+          <a:ln>
+            <a:noFill/>
+          </a:ln>
+        </p:spPr>
+        <p:style>
+          <a:lnRef idx="2">
+            <a:schemeClr val="accent1">
+              <a:shade val="15000"/>
+            </a:schemeClr>
+          </a:lnRef>
+          <a:fillRef idx="1">
+            <a:schemeClr val="accent1"/>
+          </a:fillRef>
+          <a:effectRef idx="0">
+            <a:schemeClr val="accent1"/>
+          </a:effectRef>
+          <a:fontRef idx="minor">
+            <a:schemeClr val="lt1"/>
+          </a:fontRef>
+        </p:style>
+        <p:txBody>
+          <a:bodyPr rtlCol="0" anchor="ctr"/>
+          <a:lstStyle/>
+          <a:p>
+            <a:pPr marL="0" marR="0" lvl="0" indent="0" algn="ctr" defTabSz="914400" rtl="0" eaLnBrk="1" fontAlgn="auto" latinLnBrk="0" hangingPunct="1">
+              <a:lnSpc>
+                <a:spcPct val="100000"/>
+              </a:lnSpc>
+              <a:spcBef>
+                <a:spcPts val="0"/>
+              </a:spcBef>
+              <a:spcAft>
+                <a:spcPts val="0"/>
+              </a:spcAft>
+              <a:buClrTx/>
+              <a:buSzTx/>
+              <a:buFontTx/>
+              <a:buNone/>
+              <a:tabLst/>
+              <a:defRPr/>
+            </a:pPr>
+            <a:endParaRPr kumimoji="0" lang="zh-CN" altLang="en-US" sz="1800" b="0" i="0" u="none" strike="noStrike" kern="1200" cap="none" spc="0" normalizeH="0" baseline="0" noProof="0">
+              <a:ln>
+                <a:noFill/>
+              </a:ln>
+              <a:solidFill>
+                <a:prstClr val="white"/>
+              </a:solidFill>
+              <a:effectLst/>
+              <a:uLnTx/>
+              <a:uFillTx/>
+              <a:latin typeface="等线" panose="02110004020202020204"/>
+              <a:ea typeface="等线" panose="02010600030101010101" pitchFamily="2" charset="-122"/>
+              <a:cs typeface="+mn-cs"/>
+            </a:endParaRPr>
+          </a:p>
+        </p:txBody>
+      </p:sp>
+      <p:sp>
+        <p:nvSpPr>
+          <p:cNvPr id="2" name="矩形: 圆角 1">
+            <a:extLst>
+              <a:ext uri="{FF2B5EF4-FFF2-40B4-BE49-F238E27FC236}">
+                <a16:creationId xmlns:a16="http://schemas.microsoft.com/office/drawing/2014/main" id="{EBCB5E52-C679-1B08-ED22-E1B50D22AA03}"/>
+              </a:ext>
+            </a:extLst>
+          </p:cNvPr>
+          <p:cNvSpPr/>
+          <p:nvPr/>
+        </p:nvSpPr>
+        <p:spPr>
+          <a:xfrm>
+            <a:off x="9255037" y="6115676"/>
+            <a:ext cx="2481943" cy="509451"/>
+          </a:xfrm>
+          <a:prstGeom prst="roundRect">
+            <a:avLst/>
+          </a:prstGeom>
+          <a:solidFill>
+            <a:schemeClr val="tx1"/>
+          </a:solidFill>
+          <a:ln>
+            <a:noFill/>
+          </a:ln>
+          <a:scene3d>
+            <a:camera prst="orthographicFront"/>
+            <a:lightRig rig="threePt" dir="t"/>
+          </a:scene3d>
+          <a:sp3d>
+            <a:bevelT/>
+          </a:sp3d>
+        </p:spPr>
+        <p:style>
+          <a:lnRef idx="2">
+            <a:schemeClr val="accent1">
+              <a:shade val="15000"/>
+            </a:schemeClr>
+          </a:lnRef>
+          <a:fillRef idx="1">
+            <a:schemeClr val="accent1"/>
+          </a:fillRef>
+          <a:effectRef idx="0">
+            <a:schemeClr val="accent1"/>
+          </a:effectRef>
+          <a:fontRef idx="minor">
+            <a:schemeClr val="lt1"/>
+          </a:fontRef>
+        </p:style>
+        <p:txBody>
+          <a:bodyPr rtlCol="0" anchor="ctr"/>
+          <a:lstStyle/>
+          <a:p>
+            <a:pPr marL="0" marR="0" lvl="0" indent="0" algn="ctr" defTabSz="914400" rtl="0" eaLnBrk="1" fontAlgn="auto" latinLnBrk="0" hangingPunct="1">
+              <a:lnSpc>
+                <a:spcPct val="100000"/>
+              </a:lnSpc>
+              <a:spcBef>
+                <a:spcPts val="0"/>
+              </a:spcBef>
+              <a:spcAft>
+                <a:spcPts val="0"/>
+              </a:spcAft>
+              <a:buClrTx/>
+              <a:buSzTx/>
+              <a:buFontTx/>
+              <a:buNone/>
+              <a:tabLst/>
+              <a:defRPr/>
+            </a:pPr>
+            <a:r>
+              <a:rPr kumimoji="0" lang="en-US" altLang="zh-CN" sz="1800" b="1" i="0" u="none" strike="noStrike" kern="1200" cap="none" spc="0" normalizeH="0" baseline="0" noProof="0" dirty="0">
+                <a:ln>
+                  <a:noFill/>
+                </a:ln>
+                <a:solidFill>
+                  <a:prstClr val="white"/>
+                </a:solidFill>
+                <a:effectLst/>
+                <a:uLnTx/>
+                <a:uFillTx/>
+                <a:latin typeface="等线" panose="02110004020202020204"/>
+                <a:ea typeface="等线" panose="02010600030101010101" pitchFamily="2" charset="-122"/>
+                <a:cs typeface="+mn-cs"/>
+              </a:rPr>
+              <a:t>space</a:t>
+            </a:r>
+            <a:endParaRPr kumimoji="0" lang="zh-CN" altLang="en-US" sz="1800" b="1" i="0" u="none" strike="noStrike" kern="1200" cap="none" spc="0" normalizeH="0" baseline="0" noProof="0" dirty="0">
+              <a:ln>
+                <a:noFill/>
+              </a:ln>
+              <a:solidFill>
+                <a:prstClr val="white"/>
+              </a:solidFill>
+              <a:effectLst/>
+              <a:uLnTx/>
+              <a:uFillTx/>
+              <a:latin typeface="等线" panose="02110004020202020204"/>
+              <a:ea typeface="等线" panose="02010600030101010101" pitchFamily="2" charset="-122"/>
+              <a:cs typeface="+mn-cs"/>
+            </a:endParaRPr>
+          </a:p>
+        </p:txBody>
+      </p:sp>
+      <p:sp>
+        <p:nvSpPr>
+          <p:cNvPr id="3" name="文本框 2">
+            <a:extLst>
+              <a:ext uri="{FF2B5EF4-FFF2-40B4-BE49-F238E27FC236}">
+                <a16:creationId xmlns:a16="http://schemas.microsoft.com/office/drawing/2014/main" id="{228665A7-B7D3-D636-B10E-1E9DE83C5995}"/>
+              </a:ext>
+            </a:extLst>
+          </p:cNvPr>
+          <p:cNvSpPr txBox="1"/>
+          <p:nvPr/>
+        </p:nvSpPr>
+        <p:spPr>
+          <a:xfrm>
+            <a:off x="5889913" y="6080409"/>
+            <a:ext cx="3132908" cy="523220"/>
+          </a:xfrm>
+          <a:prstGeom prst="rect">
+            <a:avLst/>
+          </a:prstGeom>
+          <a:noFill/>
+        </p:spPr>
+        <p:txBody>
+          <a:bodyPr wrap="square">
+            <a:spAutoFit/>
+          </a:bodyPr>
+          <a:lstStyle/>
+          <a:p>
+            <a:pPr marL="0" marR="0" lvl="0" indent="0" algn="ctr" defTabSz="914400" rtl="0" eaLnBrk="1" fontAlgn="auto" latinLnBrk="0" hangingPunct="1">
+              <a:lnSpc>
+                <a:spcPct val="100000"/>
+              </a:lnSpc>
+              <a:spcBef>
+                <a:spcPts val="0"/>
+              </a:spcBef>
+              <a:spcAft>
+                <a:spcPts val="0"/>
+              </a:spcAft>
+              <a:buClrTx/>
+              <a:buSzTx/>
+              <a:buFontTx/>
+              <a:buNone/>
+              <a:tabLst/>
+              <a:defRPr/>
+            </a:pPr>
+            <a:r>
+              <a:rPr kumimoji="0" lang="zh-CN" altLang="en-US" sz="2800" b="0" i="0" u="none" strike="noStrike" kern="1200" cap="none" spc="0" normalizeH="0" baseline="0" noProof="0" dirty="0">
+                <a:ln>
+                  <a:noFill/>
+                </a:ln>
+                <a:solidFill>
+                  <a:prstClr val="black"/>
+                </a:solidFill>
+                <a:effectLst/>
+                <a:uLnTx/>
+                <a:uFillTx/>
+                <a:latin typeface="楷体" panose="02010609060101010101" pitchFamily="49" charset="-122"/>
+                <a:ea typeface="楷体" panose="02010609060101010101" pitchFamily="49" charset="-122"/>
+                <a:cs typeface="+mn-cs"/>
+              </a:rPr>
+              <a:t>按“</a:t>
+            </a:r>
+            <a:r>
+              <a:rPr kumimoji="0" lang="zh-CN" altLang="en-US" sz="2800" b="1" i="0" u="sng" strike="noStrike" kern="1200" cap="none" spc="0" normalizeH="0" baseline="0" noProof="0" dirty="0">
+                <a:ln>
+                  <a:noFill/>
+                </a:ln>
+                <a:solidFill>
+                  <a:prstClr val="black"/>
+                </a:solidFill>
+                <a:effectLst/>
+                <a:uLnTx/>
+                <a:uFillTx/>
+                <a:latin typeface="楷体" panose="02010609060101010101" pitchFamily="49" charset="-122"/>
+                <a:ea typeface="楷体" panose="02010609060101010101" pitchFamily="49" charset="-122"/>
+                <a:cs typeface="+mn-cs"/>
+              </a:rPr>
+              <a:t>空格键</a:t>
+            </a:r>
+            <a:r>
+              <a:rPr kumimoji="0" lang="zh-CN" altLang="en-US" sz="2800" b="0" i="0" u="none" strike="noStrike" kern="1200" cap="none" spc="0" normalizeH="0" baseline="0" noProof="0" dirty="0">
+                <a:ln>
+                  <a:noFill/>
+                </a:ln>
+                <a:solidFill>
+                  <a:prstClr val="black"/>
+                </a:solidFill>
+                <a:effectLst/>
+                <a:uLnTx/>
+                <a:uFillTx/>
+                <a:latin typeface="楷体" panose="02010609060101010101" pitchFamily="49" charset="-122"/>
+                <a:ea typeface="楷体" panose="02010609060101010101" pitchFamily="49" charset="-122"/>
+                <a:cs typeface="+mn-cs"/>
+              </a:rPr>
+              <a:t>”</a:t>
+            </a:r>
+            <a:r>
+              <a:rPr kumimoji="0" lang="zh-CN" altLang="en-US" sz="2800" b="1" i="0" u="none" strike="noStrike" kern="1200" cap="none" spc="0" normalizeH="0" baseline="0" noProof="0" dirty="0">
+                <a:ln>
+                  <a:noFill/>
+                </a:ln>
+                <a:solidFill>
+                  <a:srgbClr val="FF0000"/>
+                </a:solidFill>
+                <a:effectLst/>
+                <a:uLnTx/>
+                <a:uFillTx/>
+                <a:latin typeface="黑体" panose="02010609060101010101" pitchFamily="49" charset="-122"/>
+                <a:ea typeface="黑体" panose="02010609060101010101" pitchFamily="49" charset="-122"/>
+                <a:cs typeface="+mn-cs"/>
+              </a:rPr>
+              <a:t>开始</a:t>
+            </a:r>
+            <a:endParaRPr kumimoji="0" lang="zh-CN" altLang="en-US" sz="1200" b="1" i="0" u="none" strike="noStrike" kern="1200" cap="none" spc="0" normalizeH="0" baseline="0" noProof="0" dirty="0">
+              <a:ln>
+                <a:noFill/>
+              </a:ln>
+              <a:solidFill>
+                <a:srgbClr val="FF0000"/>
+              </a:solidFill>
+              <a:effectLst/>
+              <a:uLnTx/>
+              <a:uFillTx/>
+              <a:latin typeface="黑体" panose="02010609060101010101" pitchFamily="49" charset="-122"/>
+              <a:ea typeface="黑体" panose="02010609060101010101" pitchFamily="49" charset="-122"/>
+              <a:cs typeface="+mn-cs"/>
+            </a:endParaRPr>
+          </a:p>
+        </p:txBody>
+      </p:sp>
+      <p:pic>
+        <p:nvPicPr>
+          <p:cNvPr id="5" name="图片 4" descr="卡通人物&#10;&#10;低可信度描述已自动生成">
+            <a:extLst>
+              <a:ext uri="{FF2B5EF4-FFF2-40B4-BE49-F238E27FC236}">
+                <a16:creationId xmlns:a16="http://schemas.microsoft.com/office/drawing/2014/main" id="{37F18B09-1B83-9ABE-94DC-CBDE5C0123A6}"/>
+              </a:ext>
+            </a:extLst>
+          </p:cNvPr>
+          <p:cNvPicPr>
+            <a:picLocks noChangeAspect="1"/>
+          </p:cNvPicPr>
+          <p:nvPr/>
+        </p:nvPicPr>
+        <p:blipFill>
+          <a:blip r:embed="rId2" cstate="hqprint">
+            <a:extLst>
+              <a:ext uri="{28A0092B-C50C-407E-A947-70E740481C1C}">
+                <a14:useLocalDpi xmlns:a14="http://schemas.microsoft.com/office/drawing/2010/main"/>
+              </a:ext>
+            </a:extLst>
+          </a:blip>
+          <a:srcRect/>
+          <a:stretch/>
+        </p:blipFill>
+        <p:spPr>
+          <a:xfrm>
+            <a:off x="9885999" y="2379054"/>
+            <a:ext cx="610009" cy="596751"/>
+          </a:xfrm>
+          <a:prstGeom prst="rect">
+            <a:avLst/>
+          </a:prstGeom>
+        </p:spPr>
+      </p:pic>
+      <p:sp>
+        <p:nvSpPr>
+          <p:cNvPr id="8" name="椭圆 7">
+            <a:extLst>
+              <a:ext uri="{FF2B5EF4-FFF2-40B4-BE49-F238E27FC236}">
+                <a16:creationId xmlns:a16="http://schemas.microsoft.com/office/drawing/2014/main" id="{EC82AC17-D982-6541-EF21-BD63B32FB9D6}"/>
+              </a:ext>
+            </a:extLst>
+          </p:cNvPr>
+          <p:cNvSpPr/>
+          <p:nvPr/>
+        </p:nvSpPr>
+        <p:spPr>
+          <a:xfrm>
+            <a:off x="10847452" y="5051714"/>
+            <a:ext cx="306977" cy="306977"/>
+          </a:xfrm>
+          <a:prstGeom prst="ellipse">
+            <a:avLst/>
+          </a:prstGeom>
+          <a:solidFill>
+            <a:srgbClr val="FFC000"/>
+          </a:solidFill>
+          <a:ln>
+            <a:noFill/>
+          </a:ln>
+        </p:spPr>
+        <p:style>
+          <a:lnRef idx="2">
+            <a:schemeClr val="accent1">
+              <a:shade val="15000"/>
+            </a:schemeClr>
+          </a:lnRef>
+          <a:fillRef idx="1">
+            <a:schemeClr val="accent1"/>
+          </a:fillRef>
+          <a:effectRef idx="0">
+            <a:schemeClr val="accent1"/>
+          </a:effectRef>
+          <a:fontRef idx="minor">
+            <a:schemeClr val="lt1"/>
+          </a:fontRef>
+        </p:style>
+        <p:txBody>
+          <a:bodyPr rtlCol="0" anchor="ctr"/>
+          <a:lstStyle/>
+          <a:p>
+            <a:pPr marL="0" marR="0" lvl="0" indent="0" algn="ctr" defTabSz="914400" rtl="0" eaLnBrk="1" fontAlgn="auto" latinLnBrk="0" hangingPunct="1">
+              <a:lnSpc>
+                <a:spcPct val="100000"/>
+              </a:lnSpc>
+              <a:spcBef>
+                <a:spcPts val="0"/>
+              </a:spcBef>
+              <a:spcAft>
+                <a:spcPts val="0"/>
+              </a:spcAft>
+              <a:buClrTx/>
+              <a:buSzTx/>
+              <a:buFontTx/>
+              <a:buNone/>
+              <a:tabLst/>
+              <a:defRPr/>
+            </a:pPr>
+            <a:endParaRPr kumimoji="0" lang="zh-CN" altLang="en-US" sz="1800" b="0" i="0" u="none" strike="noStrike" kern="1200" cap="none" spc="0" normalizeH="0" baseline="0" noProof="0">
+              <a:ln>
+                <a:noFill/>
+              </a:ln>
+              <a:solidFill>
+                <a:prstClr val="white"/>
+              </a:solidFill>
+              <a:effectLst/>
+              <a:uLnTx/>
+              <a:uFillTx/>
+              <a:latin typeface="等线" panose="02110004020202020204"/>
+              <a:ea typeface="等线" panose="02010600030101010101" pitchFamily="2" charset="-122"/>
+              <a:cs typeface="+mn-cs"/>
+            </a:endParaRPr>
+          </a:p>
+        </p:txBody>
+      </p:sp>
+    </p:spTree>
+    <p:extLst>
+      <p:ext uri="{BB962C8B-B14F-4D97-AF65-F5344CB8AC3E}">
         <p14:creationId xmlns:p14="http://schemas.microsoft.com/office/powerpoint/2010/main" val="2115238071"/>
       </p:ext>
     </p:extLst>
@@ -8608,7 +9353,7 @@
 </p:sld>
 </file>
 
-<file path=ppt/slides/slide14.xml><?xml version="1.0" encoding="utf-8"?>
+<file path=ppt/slides/slide15.xml><?xml version="1.0" encoding="utf-8"?>
 <p:sld xmlns:a="http://schemas.openxmlformats.org/drawingml/2006/main" xmlns:r="http://schemas.openxmlformats.org/officeDocument/2006/relationships" xmlns:p="http://schemas.openxmlformats.org/presentationml/2006/main">
   <p:cSld>
     <p:bg>
@@ -8924,7 +9669,7 @@
 </p:sld>
 </file>
 
-<file path=ppt/slides/slide15.xml><?xml version="1.0" encoding="utf-8"?>
+<file path=ppt/slides/slide16.xml><?xml version="1.0" encoding="utf-8"?>
 <p:sld xmlns:a="http://schemas.openxmlformats.org/drawingml/2006/main" xmlns:r="http://schemas.openxmlformats.org/officeDocument/2006/relationships" xmlns:p="http://schemas.openxmlformats.org/presentationml/2006/main">
   <p:cSld>
     <p:bg>

</xml_diff>